<commit_message>
docs: ganti "Sorotan Prioritas" jadi "Masalah Utama" + item air bersih
- Judul kolom: "Sorotan Prioritas" -> "Masalah Utama".
- Item "Peralatan navigasi/keamanan hilang" diganti "Ketersediaan air
  bersih" (JKT05 stok air tawar habis) dan dipindah ke nomor 2.
- Diterapkan pada PPTX light, HTML light, dan HTML dark.

Co-Authored-By: Claude Opus 4.8 <noreply@anthropic.com>
Claude-Session: https://claude.ai/code/session_01CKhwiCwv2GHX6ByycSGd2q
</commit_message>
<xml_diff>
--- a/docs/slides/executive-findings-18jun-01jul-2026-light.pptx
+++ b/docs/slides/executive-findings-18jun-01jul-2026-light.pptx
@@ -7377,7 +7377,7 @@
                 </a:solidFill>
                 <a:latin typeface="Calibri"/>
               </a:rPr>
-              <a:t>SOROTAN PRIORITAS — MASIH OPEN</a:t>
+              <a:t>MASALAH UTAMA — MASIH OPEN</a:t>
             </a:r>
           </a:p>
         </p:txBody>
@@ -7814,7 +7814,7 @@
                 </a:solidFill>
                 <a:latin typeface="Calibri"/>
               </a:rPr>
-              <a:t>Genangan air &amp; oli — Engine / Pump Room</a:t>
+              <a:t>Ketersediaan air bersih</a:t>
             </a:r>
           </a:p>
         </p:txBody>
@@ -7853,7 +7853,7 @@
                 </a:solidFill>
                 <a:latin typeface="Calibri"/>
               </a:rPr>
-              <a:t>BPP01 Engine Room ±60 cm air bercampur oli; JKT04 Pump Room ±10 cm.</a:t>
+              <a:t>JKT05 — stok air tawar habis; perlu penjadwalan suplai ulang air bersih.</a:t>
             </a:r>
           </a:p>
         </p:txBody>
@@ -7888,7 +7888,7 @@
                 </a:solidFill>
                 <a:latin typeface="Calibri"/>
               </a:rPr>
-              <a:t>5</a:t>
+              <a:t>1</a:t>
             </a:r>
           </a:p>
         </p:txBody>
@@ -8087,7 +8087,7 @@
                 </a:solidFill>
                 <a:latin typeface="Calibri"/>
               </a:rPr>
-              <a:t>Penerangan / lampu panel surya rusak</a:t>
+              <a:t>Genangan air &amp; oli — Engine / Pump Room</a:t>
             </a:r>
           </a:p>
         </p:txBody>
@@ -8126,7 +8126,7 @@
                 </a:solidFill>
                 <a:latin typeface="Calibri"/>
               </a:rPr>
-              <a:t>BPP01 &amp; JKT04 — penerangan malam sementara pakai senter.</a:t>
+              <a:t>BPP01 Engine Room ±60 cm air bercampur oli; JKT04 Pump Room ±10 cm.</a:t>
             </a:r>
           </a:p>
         </p:txBody>
@@ -8161,7 +8161,7 @@
                 </a:solidFill>
                 <a:latin typeface="Calibri"/>
               </a:rPr>
-              <a:t>4</a:t>
+              <a:t>5</a:t>
             </a:r>
           </a:p>
         </p:txBody>
@@ -8360,7 +8360,7 @@
                 </a:solidFill>
                 <a:latin typeface="Calibri"/>
               </a:rPr>
-              <a:t>Peralatan navigasi / keamanan hilang</a:t>
+              <a:t>Penerangan / lampu panel surya rusak</a:t>
             </a:r>
           </a:p>
         </p:txBody>
@@ -8399,7 +8399,7 @@
                 </a:solidFill>
                 <a:latin typeface="Calibri"/>
               </a:rPr>
-              <a:t>JKT05: VHF &amp; ECDIS kosong, part cargo pump diambil, pintu store terbuka.</a:t>
+              <a:t>BPP01 &amp; JKT04 — penerangan malam sementara pakai senter.</a:t>
             </a:r>
           </a:p>
         </p:txBody>
@@ -8434,7 +8434,7 @@
                 </a:solidFill>
                 <a:latin typeface="Calibri"/>
               </a:rPr>
-              <a:t>3</a:t>
+              <a:t>4</a:t>
             </a:r>
           </a:p>
         </p:txBody>

</xml_diff>

<commit_message>
docs(pptx): status penyelesaian jadi pie chart berlabel + tren jadi timeline
- Status Penyelesaian: bar diganti pie chart native (Open 26 / Selesai 7)
  dengan data label kategori + persentase.
- Tren Temuan: bar horizontal diganti horizontal timeline (garis + 3 node
  berukuran proporsional, nilai di dalam node, label periode di bawah).
- Hanya file PPTX yang diubah sesuai permintaan.

Co-Authored-By: Claude Opus 4.8 <noreply@anthropic.com>
Claude-Session: https://claude.ai/code/session_01CKhwiCwv2GHX6ByycSGd2q
</commit_message>
<xml_diff>
--- a/docs/slides/executive-findings-18jun-01jul-2026-light.pptx
+++ b/docs/slides/executive-findings-18jun-01jul-2026-light.pptx
@@ -105,6 +105,117 @@
     </a:lvl9pPr>
   </p:defaultTextStyle>
 </p:presentation>
+</file>
+
+<file path=ppt/charts/chart1.xml><?xml version="1.0" encoding="utf-8"?>
+<c:chartSpace xmlns:c="http://schemas.openxmlformats.org/drawingml/2006/chart" xmlns:a="http://schemas.openxmlformats.org/drawingml/2006/main" xmlns:r="http://schemas.openxmlformats.org/officeDocument/2006/relationships">
+  <c:chart>
+    <c:autoTitleDeleted val="1"/>
+    <c:plotArea>
+      <c:pieChart>
+        <c:varyColors/>
+        <c:ser>
+          <c:idx val="0"/>
+          <c:order val="0"/>
+          <c:tx>
+            <c:strRef>
+              <c:f>Sheet1!$B$1</c:f>
+              <c:strCache>
+                <c:ptCount val="1"/>
+                <c:pt idx="0">
+                  <c:v>Status</c:v>
+                </c:pt>
+              </c:strCache>
+            </c:strRef>
+          </c:tx>
+          <c:dPt>
+            <c:idx val="0"/>
+            <c:spPr>
+              <a:solidFill>
+                <a:srgbClr val="D97706"/>
+              </a:solidFill>
+            </c:spPr>
+          </c:dPt>
+          <c:dPt>
+            <c:idx val="1"/>
+            <c:spPr>
+              <a:solidFill>
+                <a:srgbClr val="059669"/>
+              </a:solidFill>
+            </c:spPr>
+          </c:dPt>
+          <c:cat>
+            <c:strRef>
+              <c:f>Sheet1!$A$2:$A$3</c:f>
+              <c:strCache>
+                <c:ptCount val="2"/>
+                <c:pt idx="0">
+                  <c:v>Open</c:v>
+                </c:pt>
+                <c:pt idx="1">
+                  <c:v>Selesai</c:v>
+                </c:pt>
+              </c:strCache>
+            </c:strRef>
+          </c:cat>
+          <c:val>
+            <c:numRef>
+              <c:f>Sheet1!$B$2:$B$3</c:f>
+              <c:numCache>
+                <c:formatCode>General</c:formatCode>
+                <c:ptCount val="2"/>
+                <c:pt idx="0">
+                  <c:v>26</c:v>
+                </c:pt>
+                <c:pt idx="1">
+                  <c:v>7</c:v>
+                </c:pt>
+              </c:numCache>
+            </c:numRef>
+          </c:val>
+        </c:ser>
+        <c:dLbls>
+          <c:numFmt formatCode="0%" sourceLinked="0"/>
+          <c:txPr>
+            <a:bodyPr/>
+            <a:lstStyle/>
+            <a:p>
+              <a:pPr>
+                <a:defRPr sz="850" b="1">
+                  <a:solidFill>
+                    <a:srgbClr val="0F172A"/>
+                  </a:solidFill>
+                </a:defRPr>
+              </a:pPr>
+            </a:p>
+          </c:txPr>
+          <c:dLblPos val="outEnd"/>
+          <c:showLegendKey val="0"/>
+          <c:showVal val="0"/>
+          <c:showCatName val="1"/>
+          <c:showSerName val="0"/>
+          <c:showPercent val="1"/>
+          <c:showBubbleSize val="0"/>
+          <c:showLeaderLines val="1"/>
+        </c:dLbls>
+      </c:pieChart>
+    </c:plotArea>
+    <c:dispBlanksAs val="gap"/>
+  </c:chart>
+  <c:txPr>
+    <a:bodyPr/>
+    <a:lstStyle/>
+    <a:p>
+      <a:pPr>
+        <a:defRPr sz="1800"/>
+      </a:pPr>
+      <a:endParaRPr lang="en-US"/>
+    </a:p>
+  </c:txPr>
+  <c:externalData r:id="rId1">
+    <c:autoUpdate val="0"/>
+  </c:externalData>
+</c:chartSpace>
 </file>
 
 <file path=ppt/slideLayouts/slideLayout1.xml><?xml version="1.0" encoding="utf-8"?>
@@ -4694,16 +4805,80 @@
           </a:p>
         </p:txBody>
       </p:sp>
-      <p:sp>
-        <p:nvSpPr>
-          <p:cNvPr id="38" name="TextBox 37"/>
+      <p:graphicFrame>
+        <p:nvGraphicFramePr>
+          <p:cNvPr id="38" name="Chart 37"/>
+          <p:cNvGraphicFramePr>
+            <a:graphicFrameLocks noGrp="1"/>
+          </p:cNvGraphicFramePr>
+          <p:nvPr/>
+        </p:nvGraphicFramePr>
+        <p:xfrm>
+          <a:off x="658368" y="3291840"/>
+          <a:ext cx="2915273" cy="932688"/>
+        </p:xfrm>
+        <a:graphic>
+          <a:graphicData uri="http://schemas.openxmlformats.org/drawingml/2006/chart">
+            <c:chart xmlns:c="http://schemas.openxmlformats.org/drawingml/2006/chart" r:id="rId2"/>
+          </a:graphicData>
+        </a:graphic>
+      </p:graphicFrame>
+      <p:sp>
+        <p:nvSpPr>
+          <p:cNvPr id="39" name="Rounded Rectangle 38"/>
+          <p:cNvSpPr/>
+          <p:nvPr/>
+        </p:nvSpPr>
+        <p:spPr>
+          <a:xfrm>
+            <a:off x="658368" y="4329684"/>
+            <a:ext cx="64008" cy="155448"/>
+          </a:xfrm>
+          <a:prstGeom prst="roundRect">
+            <a:avLst>
+              <a:gd name="adj" fmla="val 50000"/>
+            </a:avLst>
+          </a:prstGeom>
+          <a:solidFill>
+            <a:srgbClr val="0E7490"/>
+          </a:solidFill>
+          <a:ln>
+            <a:noFill/>
+          </a:ln>
+          <a:effectLst/>
+        </p:spPr>
+        <p:style>
+          <a:lnRef idx="1">
+            <a:schemeClr val="accent1"/>
+          </a:lnRef>
+          <a:fillRef idx="3">
+            <a:schemeClr val="accent1"/>
+          </a:fillRef>
+          <a:effectRef idx="2">
+            <a:schemeClr val="accent1"/>
+          </a:effectRef>
+          <a:fontRef idx="minor">
+            <a:schemeClr val="lt1"/>
+          </a:fontRef>
+        </p:style>
+        <p:txBody>
+          <a:bodyPr rtlCol="0" anchor="ctr"/>
+          <a:lstStyle/>
+          <a:p>
+            <a:pPr algn="ctr"/>
+          </a:p>
+        </p:txBody>
+      </p:sp>
+      <p:sp>
+        <p:nvSpPr>
+          <p:cNvPr id="40" name="TextBox 39"/>
           <p:cNvSpPr txBox="1"/>
           <p:nvPr/>
         </p:nvSpPr>
         <p:spPr>
           <a:xfrm>
-            <a:off x="658368" y="3346704"/>
-            <a:ext cx="2275193" cy="164592"/>
+            <a:off x="813816" y="4315968"/>
+            <a:ext cx="2732393" cy="182880"/>
           </a:xfrm>
           <a:prstGeom prst="rect">
             <a:avLst/>
@@ -4720,25 +4895,25 @@
             <a:r>
               <a:rPr sz="1000" b="1">
                 <a:solidFill>
-                  <a:srgbClr val="0F172A"/>
+                  <a:srgbClr val="0E7490"/>
                 </a:solidFill>
                 <a:latin typeface="Calibri"/>
               </a:rPr>
-              <a:t>Masih Open</a:t>
-            </a:r>
-          </a:p>
-        </p:txBody>
-      </p:sp>
-      <p:sp>
-        <p:nvSpPr>
-          <p:cNvPr id="39" name="TextBox 38"/>
+              <a:t>TEMUAN PER KAPAL</a:t>
+            </a:r>
+          </a:p>
+        </p:txBody>
+      </p:sp>
+      <p:sp>
+        <p:nvSpPr>
+          <p:cNvPr id="41" name="TextBox 40"/>
           <p:cNvSpPr txBox="1"/>
           <p:nvPr/>
         </p:nvSpPr>
         <p:spPr>
           <a:xfrm>
-            <a:off x="2933561" y="3346704"/>
-            <a:ext cx="640080" cy="164592"/>
+            <a:off x="658368" y="4572000"/>
+            <a:ext cx="2275193" cy="164592"/>
           </a:xfrm>
           <a:prstGeom prst="rect">
             <a:avLst/>
@@ -4751,7 +4926,7 @@
           </a:bodyPr>
           <a:lstStyle/>
           <a:p>
-            <a:pPr algn="r"/>
+            <a:pPr algn="l"/>
             <a:r>
               <a:rPr sz="1000" b="1">
                 <a:solidFill>
@@ -4759,20 +4934,55 @@
                 </a:solidFill>
                 <a:latin typeface="Calibri"/>
               </a:rPr>
-              <a:t>26</a:t>
-            </a:r>
-          </a:p>
-        </p:txBody>
-      </p:sp>
-      <p:sp>
-        <p:nvSpPr>
-          <p:cNvPr id="40" name="Rounded Rectangle 39"/>
+              <a:t>JKT05</a:t>
+            </a:r>
+          </a:p>
+        </p:txBody>
+      </p:sp>
+      <p:sp>
+        <p:nvSpPr>
+          <p:cNvPr id="42" name="TextBox 41"/>
+          <p:cNvSpPr txBox="1"/>
+          <p:nvPr/>
+        </p:nvSpPr>
+        <p:spPr>
+          <a:xfrm>
+            <a:off x="2933561" y="4572000"/>
+            <a:ext cx="640080" cy="164592"/>
+          </a:xfrm>
+          <a:prstGeom prst="rect">
+            <a:avLst/>
+          </a:prstGeom>
+          <a:noFill/>
+        </p:spPr>
+        <p:txBody>
+          <a:bodyPr wrap="square" anchor="t" lIns="0" rIns="0" tIns="0" bIns="0">
+            <a:spAutoFit/>
+          </a:bodyPr>
+          <a:lstStyle/>
+          <a:p>
+            <a:pPr algn="r"/>
+            <a:r>
+              <a:rPr sz="1000" b="1">
+                <a:solidFill>
+                  <a:srgbClr val="0F172A"/>
+                </a:solidFill>
+                <a:latin typeface="Calibri"/>
+              </a:rPr>
+              <a:t>11</a:t>
+            </a:r>
+          </a:p>
+        </p:txBody>
+      </p:sp>
+      <p:sp>
+        <p:nvSpPr>
+          <p:cNvPr id="43" name="Rounded Rectangle 42"/>
           <p:cNvSpPr/>
           <p:nvPr/>
         </p:nvSpPr>
         <p:spPr>
           <a:xfrm>
-            <a:off x="658368" y="3520440"/>
+            <a:off x="658368" y="4745736"/>
             <a:ext cx="2915273" cy="91440"/>
           </a:xfrm>
           <a:prstGeom prst="roundRect">
@@ -4812,14 +5022,14 @@
       </p:sp>
       <p:sp>
         <p:nvSpPr>
-          <p:cNvPr id="41" name="Rounded Rectangle 40"/>
+          <p:cNvPr id="44" name="Rounded Rectangle 43"/>
           <p:cNvSpPr/>
           <p:nvPr/>
         </p:nvSpPr>
         <p:spPr>
           <a:xfrm>
-            <a:off x="658368" y="3520440"/>
-            <a:ext cx="2303066" cy="91440"/>
+            <a:off x="658368" y="4745736"/>
+            <a:ext cx="2915273" cy="91440"/>
           </a:xfrm>
           <a:prstGeom prst="roundRect">
             <a:avLst>
@@ -4858,13 +5068,13 @@
       </p:sp>
       <p:sp>
         <p:nvSpPr>
-          <p:cNvPr id="42" name="TextBox 41"/>
+          <p:cNvPr id="45" name="TextBox 44"/>
           <p:cNvSpPr txBox="1"/>
           <p:nvPr/>
         </p:nvSpPr>
         <p:spPr>
           <a:xfrm>
-            <a:off x="658368" y="3657600"/>
+            <a:off x="658368" y="4846320"/>
             <a:ext cx="2275193" cy="164592"/>
           </a:xfrm>
           <a:prstGeom prst="rect">
@@ -4886,20 +5096,20 @@
                 </a:solidFill>
                 <a:latin typeface="Calibri"/>
               </a:rPr>
-              <a:t>Selesai (Closed)</a:t>
-            </a:r>
-          </a:p>
-        </p:txBody>
-      </p:sp>
-      <p:sp>
-        <p:nvSpPr>
-          <p:cNvPr id="43" name="TextBox 42"/>
+              <a:t>BPP01</a:t>
+            </a:r>
+          </a:p>
+        </p:txBody>
+      </p:sp>
+      <p:sp>
+        <p:nvSpPr>
+          <p:cNvPr id="46" name="TextBox 45"/>
           <p:cNvSpPr txBox="1"/>
           <p:nvPr/>
         </p:nvSpPr>
         <p:spPr>
           <a:xfrm>
-            <a:off x="2933561" y="3657600"/>
+            <a:off x="2933561" y="4846320"/>
             <a:ext cx="640080" cy="164592"/>
           </a:xfrm>
           <a:prstGeom prst="rect">
@@ -4921,20 +5131,20 @@
                 </a:solidFill>
                 <a:latin typeface="Calibri"/>
               </a:rPr>
-              <a:t>7</a:t>
-            </a:r>
-          </a:p>
-        </p:txBody>
-      </p:sp>
-      <p:sp>
-        <p:nvSpPr>
-          <p:cNvPr id="44" name="Rounded Rectangle 43"/>
+              <a:t>11</a:t>
+            </a:r>
+          </a:p>
+        </p:txBody>
+      </p:sp>
+      <p:sp>
+        <p:nvSpPr>
+          <p:cNvPr id="47" name="Rounded Rectangle 46"/>
           <p:cNvSpPr/>
           <p:nvPr/>
         </p:nvSpPr>
         <p:spPr>
           <a:xfrm>
-            <a:off x="658368" y="3831336"/>
+            <a:off x="658368" y="5020056"/>
             <a:ext cx="2915273" cy="91440"/>
           </a:xfrm>
           <a:prstGeom prst="roundRect">
@@ -4974,14 +5184,14 @@
       </p:sp>
       <p:sp>
         <p:nvSpPr>
-          <p:cNvPr id="45" name="Rounded Rectangle 44"/>
+          <p:cNvPr id="48" name="Rounded Rectangle 47"/>
           <p:cNvSpPr/>
           <p:nvPr/>
         </p:nvSpPr>
         <p:spPr>
           <a:xfrm>
-            <a:off x="658368" y="3831336"/>
-            <a:ext cx="612207" cy="91440"/>
+            <a:off x="658368" y="5020056"/>
+            <a:ext cx="2915273" cy="91440"/>
           </a:xfrm>
           <a:prstGeom prst="roundRect">
             <a:avLst>
@@ -4989,7 +5199,7 @@
             </a:avLst>
           </a:prstGeom>
           <a:solidFill>
-            <a:srgbClr val="059669"/>
+            <a:srgbClr val="7C3AED"/>
           </a:solidFill>
           <a:ln>
             <a:noFill/>
@@ -5020,14 +5230,292 @@
       </p:sp>
       <p:sp>
         <p:nvSpPr>
-          <p:cNvPr id="46" name="Rounded Rectangle 45"/>
+          <p:cNvPr id="49" name="TextBox 48"/>
+          <p:cNvSpPr txBox="1"/>
+          <p:nvPr/>
+        </p:nvSpPr>
+        <p:spPr>
+          <a:xfrm>
+            <a:off x="658368" y="5120640"/>
+            <a:ext cx="2275193" cy="164592"/>
+          </a:xfrm>
+          <a:prstGeom prst="rect">
+            <a:avLst/>
+          </a:prstGeom>
+          <a:noFill/>
+        </p:spPr>
+        <p:txBody>
+          <a:bodyPr wrap="square" anchor="t" lIns="0" rIns="0" tIns="0" bIns="0">
+            <a:spAutoFit/>
+          </a:bodyPr>
+          <a:lstStyle/>
+          <a:p>
+            <a:pPr algn="l"/>
+            <a:r>
+              <a:rPr sz="1000" b="1">
+                <a:solidFill>
+                  <a:srgbClr val="0F172A"/>
+                </a:solidFill>
+                <a:latin typeface="Calibri"/>
+              </a:rPr>
+              <a:t>JKT04</a:t>
+            </a:r>
+          </a:p>
+        </p:txBody>
+      </p:sp>
+      <p:sp>
+        <p:nvSpPr>
+          <p:cNvPr id="50" name="TextBox 49"/>
+          <p:cNvSpPr txBox="1"/>
+          <p:nvPr/>
+        </p:nvSpPr>
+        <p:spPr>
+          <a:xfrm>
+            <a:off x="2933561" y="5120640"/>
+            <a:ext cx="640080" cy="164592"/>
+          </a:xfrm>
+          <a:prstGeom prst="rect">
+            <a:avLst/>
+          </a:prstGeom>
+          <a:noFill/>
+        </p:spPr>
+        <p:txBody>
+          <a:bodyPr wrap="square" anchor="t" lIns="0" rIns="0" tIns="0" bIns="0">
+            <a:spAutoFit/>
+          </a:bodyPr>
+          <a:lstStyle/>
+          <a:p>
+            <a:pPr algn="r"/>
+            <a:r>
+              <a:rPr sz="1000" b="1">
+                <a:solidFill>
+                  <a:srgbClr val="0F172A"/>
+                </a:solidFill>
+                <a:latin typeface="Calibri"/>
+              </a:rPr>
+              <a:t>9</a:t>
+            </a:r>
+          </a:p>
+        </p:txBody>
+      </p:sp>
+      <p:sp>
+        <p:nvSpPr>
+          <p:cNvPr id="51" name="Rounded Rectangle 50"/>
           <p:cNvSpPr/>
           <p:nvPr/>
         </p:nvSpPr>
         <p:spPr>
           <a:xfrm>
-            <a:off x="658368" y="4110228"/>
-            <a:ext cx="64008" cy="155448"/>
+            <a:off x="658368" y="5294376"/>
+            <a:ext cx="2915273" cy="91440"/>
+          </a:xfrm>
+          <a:prstGeom prst="roundRect">
+            <a:avLst>
+              <a:gd name="adj" fmla="val 50000"/>
+            </a:avLst>
+          </a:prstGeom>
+          <a:solidFill>
+            <a:srgbClr val="ECF1F8"/>
+          </a:solidFill>
+          <a:ln>
+            <a:noFill/>
+          </a:ln>
+          <a:effectLst/>
+        </p:spPr>
+        <p:style>
+          <a:lnRef idx="1">
+            <a:schemeClr val="accent1"/>
+          </a:lnRef>
+          <a:fillRef idx="3">
+            <a:schemeClr val="accent1"/>
+          </a:fillRef>
+          <a:effectRef idx="2">
+            <a:schemeClr val="accent1"/>
+          </a:effectRef>
+          <a:fontRef idx="minor">
+            <a:schemeClr val="lt1"/>
+          </a:fontRef>
+        </p:style>
+        <p:txBody>
+          <a:bodyPr rtlCol="0" anchor="ctr"/>
+          <a:lstStyle/>
+          <a:p>
+            <a:pPr algn="ctr"/>
+          </a:p>
+        </p:txBody>
+      </p:sp>
+      <p:sp>
+        <p:nvSpPr>
+          <p:cNvPr id="52" name="Rounded Rectangle 51"/>
+          <p:cNvSpPr/>
+          <p:nvPr/>
+        </p:nvSpPr>
+        <p:spPr>
+          <a:xfrm>
+            <a:off x="658368" y="5294376"/>
+            <a:ext cx="2390524" cy="91440"/>
+          </a:xfrm>
+          <a:prstGeom prst="roundRect">
+            <a:avLst>
+              <a:gd name="adj" fmla="val 50000"/>
+            </a:avLst>
+          </a:prstGeom>
+          <a:solidFill>
+            <a:srgbClr val="D97706"/>
+          </a:solidFill>
+          <a:ln>
+            <a:noFill/>
+          </a:ln>
+          <a:effectLst/>
+        </p:spPr>
+        <p:style>
+          <a:lnRef idx="1">
+            <a:schemeClr val="accent1"/>
+          </a:lnRef>
+          <a:fillRef idx="3">
+            <a:schemeClr val="accent1"/>
+          </a:fillRef>
+          <a:effectRef idx="2">
+            <a:schemeClr val="accent1"/>
+          </a:effectRef>
+          <a:fontRef idx="minor">
+            <a:schemeClr val="lt1"/>
+          </a:fontRef>
+        </p:style>
+        <p:txBody>
+          <a:bodyPr rtlCol="0" anchor="ctr"/>
+          <a:lstStyle/>
+          <a:p>
+            <a:pPr algn="ctr"/>
+          </a:p>
+        </p:txBody>
+      </p:sp>
+      <p:sp>
+        <p:nvSpPr>
+          <p:cNvPr id="53" name="TextBox 52"/>
+          <p:cNvSpPr txBox="1"/>
+          <p:nvPr/>
+        </p:nvSpPr>
+        <p:spPr>
+          <a:xfrm>
+            <a:off x="658368" y="5394959"/>
+            <a:ext cx="2275193" cy="164592"/>
+          </a:xfrm>
+          <a:prstGeom prst="rect">
+            <a:avLst/>
+          </a:prstGeom>
+          <a:noFill/>
+        </p:spPr>
+        <p:txBody>
+          <a:bodyPr wrap="square" anchor="t" lIns="0" rIns="0" tIns="0" bIns="0">
+            <a:spAutoFit/>
+          </a:bodyPr>
+          <a:lstStyle/>
+          <a:p>
+            <a:pPr algn="l"/>
+            <a:r>
+              <a:rPr sz="1000" b="1">
+                <a:solidFill>
+                  <a:srgbClr val="0F172A"/>
+                </a:solidFill>
+                <a:latin typeface="Calibri"/>
+              </a:rPr>
+              <a:t>JKT02</a:t>
+            </a:r>
+          </a:p>
+        </p:txBody>
+      </p:sp>
+      <p:sp>
+        <p:nvSpPr>
+          <p:cNvPr id="54" name="TextBox 53"/>
+          <p:cNvSpPr txBox="1"/>
+          <p:nvPr/>
+        </p:nvSpPr>
+        <p:spPr>
+          <a:xfrm>
+            <a:off x="2933561" y="5394959"/>
+            <a:ext cx="640080" cy="164592"/>
+          </a:xfrm>
+          <a:prstGeom prst="rect">
+            <a:avLst/>
+          </a:prstGeom>
+          <a:noFill/>
+        </p:spPr>
+        <p:txBody>
+          <a:bodyPr wrap="square" anchor="t" lIns="0" rIns="0" tIns="0" bIns="0">
+            <a:spAutoFit/>
+          </a:bodyPr>
+          <a:lstStyle/>
+          <a:p>
+            <a:pPr algn="r"/>
+            <a:r>
+              <a:rPr sz="1000" b="1">
+                <a:solidFill>
+                  <a:srgbClr val="0F172A"/>
+                </a:solidFill>
+                <a:latin typeface="Calibri"/>
+              </a:rPr>
+              <a:t>2</a:t>
+            </a:r>
+          </a:p>
+        </p:txBody>
+      </p:sp>
+      <p:sp>
+        <p:nvSpPr>
+          <p:cNvPr id="55" name="Rounded Rectangle 54"/>
+          <p:cNvSpPr/>
+          <p:nvPr/>
+        </p:nvSpPr>
+        <p:spPr>
+          <a:xfrm>
+            <a:off x="658368" y="5568696"/>
+            <a:ext cx="2915273" cy="91440"/>
+          </a:xfrm>
+          <a:prstGeom prst="roundRect">
+            <a:avLst>
+              <a:gd name="adj" fmla="val 50000"/>
+            </a:avLst>
+          </a:prstGeom>
+          <a:solidFill>
+            <a:srgbClr val="ECF1F8"/>
+          </a:solidFill>
+          <a:ln>
+            <a:noFill/>
+          </a:ln>
+          <a:effectLst/>
+        </p:spPr>
+        <p:style>
+          <a:lnRef idx="1">
+            <a:schemeClr val="accent1"/>
+          </a:lnRef>
+          <a:fillRef idx="3">
+            <a:schemeClr val="accent1"/>
+          </a:fillRef>
+          <a:effectRef idx="2">
+            <a:schemeClr val="accent1"/>
+          </a:effectRef>
+          <a:fontRef idx="minor">
+            <a:schemeClr val="lt1"/>
+          </a:fontRef>
+        </p:style>
+        <p:txBody>
+          <a:bodyPr rtlCol="0" anchor="ctr"/>
+          <a:lstStyle/>
+          <a:p>
+            <a:pPr algn="ctr"/>
+          </a:p>
+        </p:txBody>
+      </p:sp>
+      <p:sp>
+        <p:nvSpPr>
+          <p:cNvPr id="56" name="Rounded Rectangle 55"/>
+          <p:cNvSpPr/>
+          <p:nvPr/>
+        </p:nvSpPr>
+        <p:spPr>
+          <a:xfrm>
+            <a:off x="658368" y="5568696"/>
+            <a:ext cx="524749" cy="91440"/>
           </a:xfrm>
           <a:prstGeom prst="roundRect">
             <a:avLst>
@@ -5066,690 +5554,7 @@
       </p:sp>
       <p:sp>
         <p:nvSpPr>
-          <p:cNvPr id="47" name="TextBox 46"/>
-          <p:cNvSpPr txBox="1"/>
-          <p:nvPr/>
-        </p:nvSpPr>
-        <p:spPr>
-          <a:xfrm>
-            <a:off x="813816" y="4096512"/>
-            <a:ext cx="2732393" cy="182880"/>
-          </a:xfrm>
-          <a:prstGeom prst="rect">
-            <a:avLst/>
-          </a:prstGeom>
-          <a:noFill/>
-        </p:spPr>
-        <p:txBody>
-          <a:bodyPr wrap="square" anchor="t" lIns="0" rIns="0" tIns="0" bIns="0">
-            <a:spAutoFit/>
-          </a:bodyPr>
-          <a:lstStyle/>
-          <a:p>
-            <a:pPr algn="l"/>
-            <a:r>
-              <a:rPr sz="1000" b="1">
-                <a:solidFill>
-                  <a:srgbClr val="0E7490"/>
-                </a:solidFill>
-                <a:latin typeface="Calibri"/>
-              </a:rPr>
-              <a:t>TEMUAN PER KAPAL</a:t>
-            </a:r>
-          </a:p>
-        </p:txBody>
-      </p:sp>
-      <p:sp>
-        <p:nvSpPr>
-          <p:cNvPr id="48" name="TextBox 47"/>
-          <p:cNvSpPr txBox="1"/>
-          <p:nvPr/>
-        </p:nvSpPr>
-        <p:spPr>
-          <a:xfrm>
-            <a:off x="658368" y="4370832"/>
-            <a:ext cx="2275193" cy="164592"/>
-          </a:xfrm>
-          <a:prstGeom prst="rect">
-            <a:avLst/>
-          </a:prstGeom>
-          <a:noFill/>
-        </p:spPr>
-        <p:txBody>
-          <a:bodyPr wrap="square" anchor="t" lIns="0" rIns="0" tIns="0" bIns="0">
-            <a:spAutoFit/>
-          </a:bodyPr>
-          <a:lstStyle/>
-          <a:p>
-            <a:pPr algn="l"/>
-            <a:r>
-              <a:rPr sz="1000" b="1">
-                <a:solidFill>
-                  <a:srgbClr val="0F172A"/>
-                </a:solidFill>
-                <a:latin typeface="Calibri"/>
-              </a:rPr>
-              <a:t>JKT05</a:t>
-            </a:r>
-          </a:p>
-        </p:txBody>
-      </p:sp>
-      <p:sp>
-        <p:nvSpPr>
-          <p:cNvPr id="49" name="TextBox 48"/>
-          <p:cNvSpPr txBox="1"/>
-          <p:nvPr/>
-        </p:nvSpPr>
-        <p:spPr>
-          <a:xfrm>
-            <a:off x="2933561" y="4370832"/>
-            <a:ext cx="640080" cy="164592"/>
-          </a:xfrm>
-          <a:prstGeom prst="rect">
-            <a:avLst/>
-          </a:prstGeom>
-          <a:noFill/>
-        </p:spPr>
-        <p:txBody>
-          <a:bodyPr wrap="square" anchor="t" lIns="0" rIns="0" tIns="0" bIns="0">
-            <a:spAutoFit/>
-          </a:bodyPr>
-          <a:lstStyle/>
-          <a:p>
-            <a:pPr algn="r"/>
-            <a:r>
-              <a:rPr sz="1000" b="1">
-                <a:solidFill>
-                  <a:srgbClr val="0F172A"/>
-                </a:solidFill>
-                <a:latin typeface="Calibri"/>
-              </a:rPr>
-              <a:t>11</a:t>
-            </a:r>
-          </a:p>
-        </p:txBody>
-      </p:sp>
-      <p:sp>
-        <p:nvSpPr>
-          <p:cNvPr id="50" name="Rounded Rectangle 49"/>
-          <p:cNvSpPr/>
-          <p:nvPr/>
-        </p:nvSpPr>
-        <p:spPr>
-          <a:xfrm>
-            <a:off x="658368" y="4544568"/>
-            <a:ext cx="2915273" cy="91440"/>
-          </a:xfrm>
-          <a:prstGeom prst="roundRect">
-            <a:avLst>
-              <a:gd name="adj" fmla="val 50000"/>
-            </a:avLst>
-          </a:prstGeom>
-          <a:solidFill>
-            <a:srgbClr val="ECF1F8"/>
-          </a:solidFill>
-          <a:ln>
-            <a:noFill/>
-          </a:ln>
-          <a:effectLst/>
-        </p:spPr>
-        <p:style>
-          <a:lnRef idx="1">
-            <a:schemeClr val="accent1"/>
-          </a:lnRef>
-          <a:fillRef idx="3">
-            <a:schemeClr val="accent1"/>
-          </a:fillRef>
-          <a:effectRef idx="2">
-            <a:schemeClr val="accent1"/>
-          </a:effectRef>
-          <a:fontRef idx="minor">
-            <a:schemeClr val="lt1"/>
-          </a:fontRef>
-        </p:style>
-        <p:txBody>
-          <a:bodyPr rtlCol="0" anchor="ctr"/>
-          <a:lstStyle/>
-          <a:p>
-            <a:pPr algn="ctr"/>
-          </a:p>
-        </p:txBody>
-      </p:sp>
-      <p:sp>
-        <p:nvSpPr>
-          <p:cNvPr id="51" name="Rounded Rectangle 50"/>
-          <p:cNvSpPr/>
-          <p:nvPr/>
-        </p:nvSpPr>
-        <p:spPr>
-          <a:xfrm>
-            <a:off x="658368" y="4544568"/>
-            <a:ext cx="2915273" cy="91440"/>
-          </a:xfrm>
-          <a:prstGeom prst="roundRect">
-            <a:avLst>
-              <a:gd name="adj" fmla="val 50000"/>
-            </a:avLst>
-          </a:prstGeom>
-          <a:solidFill>
-            <a:srgbClr val="D97706"/>
-          </a:solidFill>
-          <a:ln>
-            <a:noFill/>
-          </a:ln>
-          <a:effectLst/>
-        </p:spPr>
-        <p:style>
-          <a:lnRef idx="1">
-            <a:schemeClr val="accent1"/>
-          </a:lnRef>
-          <a:fillRef idx="3">
-            <a:schemeClr val="accent1"/>
-          </a:fillRef>
-          <a:effectRef idx="2">
-            <a:schemeClr val="accent1"/>
-          </a:effectRef>
-          <a:fontRef idx="minor">
-            <a:schemeClr val="lt1"/>
-          </a:fontRef>
-        </p:style>
-        <p:txBody>
-          <a:bodyPr rtlCol="0" anchor="ctr"/>
-          <a:lstStyle/>
-          <a:p>
-            <a:pPr algn="ctr"/>
-          </a:p>
-        </p:txBody>
-      </p:sp>
-      <p:sp>
-        <p:nvSpPr>
-          <p:cNvPr id="52" name="TextBox 51"/>
-          <p:cNvSpPr txBox="1"/>
-          <p:nvPr/>
-        </p:nvSpPr>
-        <p:spPr>
-          <a:xfrm>
-            <a:off x="658368" y="4677156"/>
-            <a:ext cx="2275193" cy="164592"/>
-          </a:xfrm>
-          <a:prstGeom prst="rect">
-            <a:avLst/>
-          </a:prstGeom>
-          <a:noFill/>
-        </p:spPr>
-        <p:txBody>
-          <a:bodyPr wrap="square" anchor="t" lIns="0" rIns="0" tIns="0" bIns="0">
-            <a:spAutoFit/>
-          </a:bodyPr>
-          <a:lstStyle/>
-          <a:p>
-            <a:pPr algn="l"/>
-            <a:r>
-              <a:rPr sz="1000" b="1">
-                <a:solidFill>
-                  <a:srgbClr val="0F172A"/>
-                </a:solidFill>
-                <a:latin typeface="Calibri"/>
-              </a:rPr>
-              <a:t>BPP01</a:t>
-            </a:r>
-          </a:p>
-        </p:txBody>
-      </p:sp>
-      <p:sp>
-        <p:nvSpPr>
-          <p:cNvPr id="53" name="TextBox 52"/>
-          <p:cNvSpPr txBox="1"/>
-          <p:nvPr/>
-        </p:nvSpPr>
-        <p:spPr>
-          <a:xfrm>
-            <a:off x="2933561" y="4677156"/>
-            <a:ext cx="640080" cy="164592"/>
-          </a:xfrm>
-          <a:prstGeom prst="rect">
-            <a:avLst/>
-          </a:prstGeom>
-          <a:noFill/>
-        </p:spPr>
-        <p:txBody>
-          <a:bodyPr wrap="square" anchor="t" lIns="0" rIns="0" tIns="0" bIns="0">
-            <a:spAutoFit/>
-          </a:bodyPr>
-          <a:lstStyle/>
-          <a:p>
-            <a:pPr algn="r"/>
-            <a:r>
-              <a:rPr sz="1000" b="1">
-                <a:solidFill>
-                  <a:srgbClr val="0F172A"/>
-                </a:solidFill>
-                <a:latin typeface="Calibri"/>
-              </a:rPr>
-              <a:t>11</a:t>
-            </a:r>
-          </a:p>
-        </p:txBody>
-      </p:sp>
-      <p:sp>
-        <p:nvSpPr>
-          <p:cNvPr id="54" name="Rounded Rectangle 53"/>
-          <p:cNvSpPr/>
-          <p:nvPr/>
-        </p:nvSpPr>
-        <p:spPr>
-          <a:xfrm>
-            <a:off x="658368" y="4850892"/>
-            <a:ext cx="2915273" cy="91440"/>
-          </a:xfrm>
-          <a:prstGeom prst="roundRect">
-            <a:avLst>
-              <a:gd name="adj" fmla="val 50000"/>
-            </a:avLst>
-          </a:prstGeom>
-          <a:solidFill>
-            <a:srgbClr val="ECF1F8"/>
-          </a:solidFill>
-          <a:ln>
-            <a:noFill/>
-          </a:ln>
-          <a:effectLst/>
-        </p:spPr>
-        <p:style>
-          <a:lnRef idx="1">
-            <a:schemeClr val="accent1"/>
-          </a:lnRef>
-          <a:fillRef idx="3">
-            <a:schemeClr val="accent1"/>
-          </a:fillRef>
-          <a:effectRef idx="2">
-            <a:schemeClr val="accent1"/>
-          </a:effectRef>
-          <a:fontRef idx="minor">
-            <a:schemeClr val="lt1"/>
-          </a:fontRef>
-        </p:style>
-        <p:txBody>
-          <a:bodyPr rtlCol="0" anchor="ctr"/>
-          <a:lstStyle/>
-          <a:p>
-            <a:pPr algn="ctr"/>
-          </a:p>
-        </p:txBody>
-      </p:sp>
-      <p:sp>
-        <p:nvSpPr>
-          <p:cNvPr id="55" name="Rounded Rectangle 54"/>
-          <p:cNvSpPr/>
-          <p:nvPr/>
-        </p:nvSpPr>
-        <p:spPr>
-          <a:xfrm>
-            <a:off x="658368" y="4850892"/>
-            <a:ext cx="2915273" cy="91440"/>
-          </a:xfrm>
-          <a:prstGeom prst="roundRect">
-            <a:avLst>
-              <a:gd name="adj" fmla="val 50000"/>
-            </a:avLst>
-          </a:prstGeom>
-          <a:solidFill>
-            <a:srgbClr val="7C3AED"/>
-          </a:solidFill>
-          <a:ln>
-            <a:noFill/>
-          </a:ln>
-          <a:effectLst/>
-        </p:spPr>
-        <p:style>
-          <a:lnRef idx="1">
-            <a:schemeClr val="accent1"/>
-          </a:lnRef>
-          <a:fillRef idx="3">
-            <a:schemeClr val="accent1"/>
-          </a:fillRef>
-          <a:effectRef idx="2">
-            <a:schemeClr val="accent1"/>
-          </a:effectRef>
-          <a:fontRef idx="minor">
-            <a:schemeClr val="lt1"/>
-          </a:fontRef>
-        </p:style>
-        <p:txBody>
-          <a:bodyPr rtlCol="0" anchor="ctr"/>
-          <a:lstStyle/>
-          <a:p>
-            <a:pPr algn="ctr"/>
-          </a:p>
-        </p:txBody>
-      </p:sp>
-      <p:sp>
-        <p:nvSpPr>
-          <p:cNvPr id="56" name="TextBox 55"/>
-          <p:cNvSpPr txBox="1"/>
-          <p:nvPr/>
-        </p:nvSpPr>
-        <p:spPr>
-          <a:xfrm>
-            <a:off x="658368" y="4983480"/>
-            <a:ext cx="2275193" cy="164592"/>
-          </a:xfrm>
-          <a:prstGeom prst="rect">
-            <a:avLst/>
-          </a:prstGeom>
-          <a:noFill/>
-        </p:spPr>
-        <p:txBody>
-          <a:bodyPr wrap="square" anchor="t" lIns="0" rIns="0" tIns="0" bIns="0">
-            <a:spAutoFit/>
-          </a:bodyPr>
-          <a:lstStyle/>
-          <a:p>
-            <a:pPr algn="l"/>
-            <a:r>
-              <a:rPr sz="1000" b="1">
-                <a:solidFill>
-                  <a:srgbClr val="0F172A"/>
-                </a:solidFill>
-                <a:latin typeface="Calibri"/>
-              </a:rPr>
-              <a:t>JKT04</a:t>
-            </a:r>
-          </a:p>
-        </p:txBody>
-      </p:sp>
-      <p:sp>
-        <p:nvSpPr>
-          <p:cNvPr id="57" name="TextBox 56"/>
-          <p:cNvSpPr txBox="1"/>
-          <p:nvPr/>
-        </p:nvSpPr>
-        <p:spPr>
-          <a:xfrm>
-            <a:off x="2933561" y="4983480"/>
-            <a:ext cx="640080" cy="164592"/>
-          </a:xfrm>
-          <a:prstGeom prst="rect">
-            <a:avLst/>
-          </a:prstGeom>
-          <a:noFill/>
-        </p:spPr>
-        <p:txBody>
-          <a:bodyPr wrap="square" anchor="t" lIns="0" rIns="0" tIns="0" bIns="0">
-            <a:spAutoFit/>
-          </a:bodyPr>
-          <a:lstStyle/>
-          <a:p>
-            <a:pPr algn="r"/>
-            <a:r>
-              <a:rPr sz="1000" b="1">
-                <a:solidFill>
-                  <a:srgbClr val="0F172A"/>
-                </a:solidFill>
-                <a:latin typeface="Calibri"/>
-              </a:rPr>
-              <a:t>9</a:t>
-            </a:r>
-          </a:p>
-        </p:txBody>
-      </p:sp>
-      <p:sp>
-        <p:nvSpPr>
-          <p:cNvPr id="58" name="Rounded Rectangle 57"/>
-          <p:cNvSpPr/>
-          <p:nvPr/>
-        </p:nvSpPr>
-        <p:spPr>
-          <a:xfrm>
-            <a:off x="658368" y="5157216"/>
-            <a:ext cx="2915273" cy="91440"/>
-          </a:xfrm>
-          <a:prstGeom prst="roundRect">
-            <a:avLst>
-              <a:gd name="adj" fmla="val 50000"/>
-            </a:avLst>
-          </a:prstGeom>
-          <a:solidFill>
-            <a:srgbClr val="ECF1F8"/>
-          </a:solidFill>
-          <a:ln>
-            <a:noFill/>
-          </a:ln>
-          <a:effectLst/>
-        </p:spPr>
-        <p:style>
-          <a:lnRef idx="1">
-            <a:schemeClr val="accent1"/>
-          </a:lnRef>
-          <a:fillRef idx="3">
-            <a:schemeClr val="accent1"/>
-          </a:fillRef>
-          <a:effectRef idx="2">
-            <a:schemeClr val="accent1"/>
-          </a:effectRef>
-          <a:fontRef idx="minor">
-            <a:schemeClr val="lt1"/>
-          </a:fontRef>
-        </p:style>
-        <p:txBody>
-          <a:bodyPr rtlCol="0" anchor="ctr"/>
-          <a:lstStyle/>
-          <a:p>
-            <a:pPr algn="ctr"/>
-          </a:p>
-        </p:txBody>
-      </p:sp>
-      <p:sp>
-        <p:nvSpPr>
-          <p:cNvPr id="59" name="Rounded Rectangle 58"/>
-          <p:cNvSpPr/>
-          <p:nvPr/>
-        </p:nvSpPr>
-        <p:spPr>
-          <a:xfrm>
-            <a:off x="658368" y="5157216"/>
-            <a:ext cx="2390524" cy="91440"/>
-          </a:xfrm>
-          <a:prstGeom prst="roundRect">
-            <a:avLst>
-              <a:gd name="adj" fmla="val 50000"/>
-            </a:avLst>
-          </a:prstGeom>
-          <a:solidFill>
-            <a:srgbClr val="D97706"/>
-          </a:solidFill>
-          <a:ln>
-            <a:noFill/>
-          </a:ln>
-          <a:effectLst/>
-        </p:spPr>
-        <p:style>
-          <a:lnRef idx="1">
-            <a:schemeClr val="accent1"/>
-          </a:lnRef>
-          <a:fillRef idx="3">
-            <a:schemeClr val="accent1"/>
-          </a:fillRef>
-          <a:effectRef idx="2">
-            <a:schemeClr val="accent1"/>
-          </a:effectRef>
-          <a:fontRef idx="minor">
-            <a:schemeClr val="lt1"/>
-          </a:fontRef>
-        </p:style>
-        <p:txBody>
-          <a:bodyPr rtlCol="0" anchor="ctr"/>
-          <a:lstStyle/>
-          <a:p>
-            <a:pPr algn="ctr"/>
-          </a:p>
-        </p:txBody>
-      </p:sp>
-      <p:sp>
-        <p:nvSpPr>
-          <p:cNvPr id="60" name="TextBox 59"/>
-          <p:cNvSpPr txBox="1"/>
-          <p:nvPr/>
-        </p:nvSpPr>
-        <p:spPr>
-          <a:xfrm>
-            <a:off x="658368" y="5289804"/>
-            <a:ext cx="2275193" cy="164592"/>
-          </a:xfrm>
-          <a:prstGeom prst="rect">
-            <a:avLst/>
-          </a:prstGeom>
-          <a:noFill/>
-        </p:spPr>
-        <p:txBody>
-          <a:bodyPr wrap="square" anchor="t" lIns="0" rIns="0" tIns="0" bIns="0">
-            <a:spAutoFit/>
-          </a:bodyPr>
-          <a:lstStyle/>
-          <a:p>
-            <a:pPr algn="l"/>
-            <a:r>
-              <a:rPr sz="1000" b="1">
-                <a:solidFill>
-                  <a:srgbClr val="0F172A"/>
-                </a:solidFill>
-                <a:latin typeface="Calibri"/>
-              </a:rPr>
-              <a:t>JKT02</a:t>
-            </a:r>
-          </a:p>
-        </p:txBody>
-      </p:sp>
-      <p:sp>
-        <p:nvSpPr>
-          <p:cNvPr id="61" name="TextBox 60"/>
-          <p:cNvSpPr txBox="1"/>
-          <p:nvPr/>
-        </p:nvSpPr>
-        <p:spPr>
-          <a:xfrm>
-            <a:off x="2933561" y="5289804"/>
-            <a:ext cx="640080" cy="164592"/>
-          </a:xfrm>
-          <a:prstGeom prst="rect">
-            <a:avLst/>
-          </a:prstGeom>
-          <a:noFill/>
-        </p:spPr>
-        <p:txBody>
-          <a:bodyPr wrap="square" anchor="t" lIns="0" rIns="0" tIns="0" bIns="0">
-            <a:spAutoFit/>
-          </a:bodyPr>
-          <a:lstStyle/>
-          <a:p>
-            <a:pPr algn="r"/>
-            <a:r>
-              <a:rPr sz="1000" b="1">
-                <a:solidFill>
-                  <a:srgbClr val="0F172A"/>
-                </a:solidFill>
-                <a:latin typeface="Calibri"/>
-              </a:rPr>
-              <a:t>2</a:t>
-            </a:r>
-          </a:p>
-        </p:txBody>
-      </p:sp>
-      <p:sp>
-        <p:nvSpPr>
-          <p:cNvPr id="62" name="Rounded Rectangle 61"/>
-          <p:cNvSpPr/>
-          <p:nvPr/>
-        </p:nvSpPr>
-        <p:spPr>
-          <a:xfrm>
-            <a:off x="658368" y="5463540"/>
-            <a:ext cx="2915273" cy="91440"/>
-          </a:xfrm>
-          <a:prstGeom prst="roundRect">
-            <a:avLst>
-              <a:gd name="adj" fmla="val 50000"/>
-            </a:avLst>
-          </a:prstGeom>
-          <a:solidFill>
-            <a:srgbClr val="ECF1F8"/>
-          </a:solidFill>
-          <a:ln>
-            <a:noFill/>
-          </a:ln>
-          <a:effectLst/>
-        </p:spPr>
-        <p:style>
-          <a:lnRef idx="1">
-            <a:schemeClr val="accent1"/>
-          </a:lnRef>
-          <a:fillRef idx="3">
-            <a:schemeClr val="accent1"/>
-          </a:fillRef>
-          <a:effectRef idx="2">
-            <a:schemeClr val="accent1"/>
-          </a:effectRef>
-          <a:fontRef idx="minor">
-            <a:schemeClr val="lt1"/>
-          </a:fontRef>
-        </p:style>
-        <p:txBody>
-          <a:bodyPr rtlCol="0" anchor="ctr"/>
-          <a:lstStyle/>
-          <a:p>
-            <a:pPr algn="ctr"/>
-          </a:p>
-        </p:txBody>
-      </p:sp>
-      <p:sp>
-        <p:nvSpPr>
-          <p:cNvPr id="63" name="Rounded Rectangle 62"/>
-          <p:cNvSpPr/>
-          <p:nvPr/>
-        </p:nvSpPr>
-        <p:spPr>
-          <a:xfrm>
-            <a:off x="658368" y="5463540"/>
-            <a:ext cx="524749" cy="91440"/>
-          </a:xfrm>
-          <a:prstGeom prst="roundRect">
-            <a:avLst>
-              <a:gd name="adj" fmla="val 50000"/>
-            </a:avLst>
-          </a:prstGeom>
-          <a:solidFill>
-            <a:srgbClr val="0E7490"/>
-          </a:solidFill>
-          <a:ln>
-            <a:noFill/>
-          </a:ln>
-          <a:effectLst/>
-        </p:spPr>
-        <p:style>
-          <a:lnRef idx="1">
-            <a:schemeClr val="accent1"/>
-          </a:lnRef>
-          <a:fillRef idx="3">
-            <a:schemeClr val="accent1"/>
-          </a:fillRef>
-          <a:effectRef idx="2">
-            <a:schemeClr val="accent1"/>
-          </a:effectRef>
-          <a:fontRef idx="minor">
-            <a:schemeClr val="lt1"/>
-          </a:fontRef>
-        </p:style>
-        <p:txBody>
-          <a:bodyPr rtlCol="0" anchor="ctr"/>
-          <a:lstStyle/>
-          <a:p>
-            <a:pPr algn="ctr"/>
-          </a:p>
-        </p:txBody>
-      </p:sp>
-      <p:sp>
-        <p:nvSpPr>
-          <p:cNvPr id="64" name="Rounded Rectangle 63"/>
+          <p:cNvPr id="57" name="Rounded Rectangle 56"/>
           <p:cNvSpPr/>
           <p:nvPr/>
         </p:nvSpPr>
@@ -5797,7 +5602,7 @@
       </p:sp>
       <p:sp>
         <p:nvSpPr>
-          <p:cNvPr id="65" name="Rounded Rectangle 64"/>
+          <p:cNvPr id="58" name="Rounded Rectangle 57"/>
           <p:cNvSpPr/>
           <p:nvPr/>
         </p:nvSpPr>
@@ -5843,7 +5648,7 @@
       </p:sp>
       <p:sp>
         <p:nvSpPr>
-          <p:cNvPr id="66" name="TextBox 65"/>
+          <p:cNvPr id="59" name="TextBox 58"/>
           <p:cNvSpPr txBox="1"/>
           <p:nvPr/>
         </p:nvSpPr>
@@ -5878,7 +5683,7 @@
       </p:sp>
       <p:sp>
         <p:nvSpPr>
-          <p:cNvPr id="67" name="TextBox 66"/>
+          <p:cNvPr id="60" name="TextBox 59"/>
           <p:cNvSpPr txBox="1"/>
           <p:nvPr/>
         </p:nvSpPr>
@@ -5913,7 +5718,7 @@
       </p:sp>
       <p:sp>
         <p:nvSpPr>
-          <p:cNvPr id="68" name="TextBox 67"/>
+          <p:cNvPr id="61" name="TextBox 60"/>
           <p:cNvSpPr txBox="1"/>
           <p:nvPr/>
         </p:nvSpPr>
@@ -5948,7 +5753,7 @@
       </p:sp>
       <p:sp>
         <p:nvSpPr>
-          <p:cNvPr id="69" name="Rounded Rectangle 68"/>
+          <p:cNvPr id="62" name="Rounded Rectangle 61"/>
           <p:cNvSpPr/>
           <p:nvPr/>
         </p:nvSpPr>
@@ -5994,7 +5799,7 @@
       </p:sp>
       <p:sp>
         <p:nvSpPr>
-          <p:cNvPr id="70" name="Rounded Rectangle 69"/>
+          <p:cNvPr id="63" name="Rounded Rectangle 62"/>
           <p:cNvSpPr/>
           <p:nvPr/>
         </p:nvSpPr>
@@ -6040,7 +5845,7 @@
       </p:sp>
       <p:sp>
         <p:nvSpPr>
-          <p:cNvPr id="71" name="TextBox 70"/>
+          <p:cNvPr id="64" name="TextBox 63"/>
           <p:cNvSpPr txBox="1"/>
           <p:nvPr/>
         </p:nvSpPr>
@@ -6075,7 +5880,7 @@
       </p:sp>
       <p:sp>
         <p:nvSpPr>
-          <p:cNvPr id="72" name="TextBox 71"/>
+          <p:cNvPr id="65" name="TextBox 64"/>
           <p:cNvSpPr txBox="1"/>
           <p:nvPr/>
         </p:nvSpPr>
@@ -6110,7 +5915,7 @@
       </p:sp>
       <p:sp>
         <p:nvSpPr>
-          <p:cNvPr id="73" name="Rounded Rectangle 72"/>
+          <p:cNvPr id="66" name="Rounded Rectangle 65"/>
           <p:cNvSpPr/>
           <p:nvPr/>
         </p:nvSpPr>
@@ -6156,7 +5961,7 @@
       </p:sp>
       <p:sp>
         <p:nvSpPr>
-          <p:cNvPr id="74" name="Rounded Rectangle 73"/>
+          <p:cNvPr id="67" name="Rounded Rectangle 66"/>
           <p:cNvSpPr/>
           <p:nvPr/>
         </p:nvSpPr>
@@ -6202,7 +6007,7 @@
       </p:sp>
       <p:sp>
         <p:nvSpPr>
-          <p:cNvPr id="75" name="TextBox 74"/>
+          <p:cNvPr id="68" name="TextBox 67"/>
           <p:cNvSpPr txBox="1"/>
           <p:nvPr/>
         </p:nvSpPr>
@@ -6237,7 +6042,7 @@
       </p:sp>
       <p:sp>
         <p:nvSpPr>
-          <p:cNvPr id="76" name="TextBox 75"/>
+          <p:cNvPr id="69" name="TextBox 68"/>
           <p:cNvSpPr txBox="1"/>
           <p:nvPr/>
         </p:nvSpPr>
@@ -6272,7 +6077,7 @@
       </p:sp>
       <p:sp>
         <p:nvSpPr>
-          <p:cNvPr id="77" name="Rounded Rectangle 76"/>
+          <p:cNvPr id="70" name="Rounded Rectangle 69"/>
           <p:cNvSpPr/>
           <p:nvPr/>
         </p:nvSpPr>
@@ -6318,7 +6123,7 @@
       </p:sp>
       <p:sp>
         <p:nvSpPr>
-          <p:cNvPr id="78" name="Rounded Rectangle 77"/>
+          <p:cNvPr id="71" name="Rounded Rectangle 70"/>
           <p:cNvSpPr/>
           <p:nvPr/>
         </p:nvSpPr>
@@ -6364,7 +6169,7 @@
       </p:sp>
       <p:sp>
         <p:nvSpPr>
-          <p:cNvPr id="79" name="TextBox 78"/>
+          <p:cNvPr id="72" name="TextBox 71"/>
           <p:cNvSpPr txBox="1"/>
           <p:nvPr/>
         </p:nvSpPr>
@@ -6399,7 +6204,7 @@
       </p:sp>
       <p:sp>
         <p:nvSpPr>
-          <p:cNvPr id="80" name="TextBox 79"/>
+          <p:cNvPr id="73" name="TextBox 72"/>
           <p:cNvSpPr txBox="1"/>
           <p:nvPr/>
         </p:nvSpPr>
@@ -6434,7 +6239,7 @@
       </p:sp>
       <p:sp>
         <p:nvSpPr>
-          <p:cNvPr id="81" name="Rounded Rectangle 80"/>
+          <p:cNvPr id="74" name="Rounded Rectangle 73"/>
           <p:cNvSpPr/>
           <p:nvPr/>
         </p:nvSpPr>
@@ -6480,7 +6285,7 @@
       </p:sp>
       <p:sp>
         <p:nvSpPr>
-          <p:cNvPr id="82" name="Rounded Rectangle 81"/>
+          <p:cNvPr id="75" name="Rounded Rectangle 74"/>
           <p:cNvSpPr/>
           <p:nvPr/>
         </p:nvSpPr>
@@ -6526,7 +6331,7 @@
       </p:sp>
       <p:sp>
         <p:nvSpPr>
-          <p:cNvPr id="83" name="TextBox 82"/>
+          <p:cNvPr id="76" name="TextBox 75"/>
           <p:cNvSpPr txBox="1"/>
           <p:nvPr/>
         </p:nvSpPr>
@@ -6561,7 +6366,7 @@
       </p:sp>
       <p:sp>
         <p:nvSpPr>
-          <p:cNvPr id="84" name="TextBox 83"/>
+          <p:cNvPr id="77" name="TextBox 76"/>
           <p:cNvSpPr txBox="1"/>
           <p:nvPr/>
         </p:nvSpPr>
@@ -6596,7 +6401,7 @@
       </p:sp>
       <p:sp>
         <p:nvSpPr>
-          <p:cNvPr id="85" name="Rounded Rectangle 84"/>
+          <p:cNvPr id="78" name="Rounded Rectangle 77"/>
           <p:cNvSpPr/>
           <p:nvPr/>
         </p:nvSpPr>
@@ -6642,7 +6447,7 @@
       </p:sp>
       <p:sp>
         <p:nvSpPr>
-          <p:cNvPr id="86" name="Rounded Rectangle 85"/>
+          <p:cNvPr id="79" name="Rounded Rectangle 78"/>
           <p:cNvSpPr/>
           <p:nvPr/>
         </p:nvSpPr>
@@ -6688,7 +6493,7 @@
       </p:sp>
       <p:sp>
         <p:nvSpPr>
-          <p:cNvPr id="87" name="Rounded Rectangle 86"/>
+          <p:cNvPr id="80" name="Rounded Rectangle 79"/>
           <p:cNvSpPr/>
           <p:nvPr/>
         </p:nvSpPr>
@@ -6734,7 +6539,7 @@
       </p:sp>
       <p:sp>
         <p:nvSpPr>
-          <p:cNvPr id="88" name="TextBox 87"/>
+          <p:cNvPr id="81" name="TextBox 80"/>
           <p:cNvSpPr txBox="1"/>
           <p:nvPr/>
         </p:nvSpPr>
@@ -6762,99 +6567,27 @@
                 </a:solidFill>
                 <a:latin typeface="Calibri"/>
               </a:rPr>
-              <a:t>TREN TEMUAN (SUBSTANTIF)</a:t>
-            </a:r>
-          </a:p>
-        </p:txBody>
-      </p:sp>
-      <p:sp>
-        <p:nvSpPr>
-          <p:cNvPr id="89" name="TextBox 88"/>
-          <p:cNvSpPr txBox="1"/>
-          <p:nvPr/>
-        </p:nvSpPr>
-        <p:spPr>
-          <a:xfrm>
-            <a:off x="4140569" y="4974336"/>
-            <a:ext cx="2275193" cy="164592"/>
+              <a:t>TREN TEMUAN — TIMELINE</a:t>
+            </a:r>
+          </a:p>
+        </p:txBody>
+      </p:sp>
+      <p:sp>
+        <p:nvSpPr>
+          <p:cNvPr id="82" name="Rectangle 81"/>
+          <p:cNvSpPr/>
+          <p:nvPr/>
+        </p:nvSpPr>
+        <p:spPr>
+          <a:xfrm>
+            <a:off x="4643489" y="5216652"/>
+            <a:ext cx="1909433" cy="27432"/>
           </a:xfrm>
           <a:prstGeom prst="rect">
             <a:avLst/>
           </a:prstGeom>
-          <a:noFill/>
-        </p:spPr>
-        <p:txBody>
-          <a:bodyPr wrap="square" anchor="t" lIns="0" rIns="0" tIns="0" bIns="0">
-            <a:spAutoFit/>
-          </a:bodyPr>
-          <a:lstStyle/>
-          <a:p>
-            <a:pPr algn="l"/>
-            <a:r>
-              <a:rPr sz="1000" b="1">
-                <a:solidFill>
-                  <a:srgbClr val="0F172A"/>
-                </a:solidFill>
-                <a:latin typeface="Calibri"/>
-              </a:rPr>
-              <a:t>18–21 Jun</a:t>
-            </a:r>
-          </a:p>
-        </p:txBody>
-      </p:sp>
-      <p:sp>
-        <p:nvSpPr>
-          <p:cNvPr id="90" name="TextBox 89"/>
-          <p:cNvSpPr txBox="1"/>
-          <p:nvPr/>
-        </p:nvSpPr>
-        <p:spPr>
-          <a:xfrm>
-            <a:off x="6415762" y="4974336"/>
-            <a:ext cx="640080" cy="164592"/>
-          </a:xfrm>
-          <a:prstGeom prst="rect">
-            <a:avLst/>
-          </a:prstGeom>
-          <a:noFill/>
-        </p:spPr>
-        <p:txBody>
-          <a:bodyPr wrap="square" anchor="t" lIns="0" rIns="0" tIns="0" bIns="0">
-            <a:spAutoFit/>
-          </a:bodyPr>
-          <a:lstStyle/>
-          <a:p>
-            <a:pPr algn="r"/>
-            <a:r>
-              <a:rPr sz="1000" b="1">
-                <a:solidFill>
-                  <a:srgbClr val="0F172A"/>
-                </a:solidFill>
-                <a:latin typeface="Calibri"/>
-              </a:rPr>
-              <a:t>4</a:t>
-            </a:r>
-          </a:p>
-        </p:txBody>
-      </p:sp>
-      <p:sp>
-        <p:nvSpPr>
-          <p:cNvPr id="91" name="Rounded Rectangle 90"/>
-          <p:cNvSpPr/>
-          <p:nvPr/>
-        </p:nvSpPr>
-        <p:spPr>
-          <a:xfrm>
-            <a:off x="4140569" y="5148072"/>
-            <a:ext cx="2915273" cy="91440"/>
-          </a:xfrm>
-          <a:prstGeom prst="roundRect">
-            <a:avLst>
-              <a:gd name="adj" fmla="val 50000"/>
-            </a:avLst>
-          </a:prstGeom>
           <a:solidFill>
-            <a:srgbClr val="ECF1F8"/>
+            <a:srgbClr val="C7D3E6"/>
           </a:solidFill>
           <a:ln>
             <a:noFill/>
@@ -6885,19 +6618,17 @@
       </p:sp>
       <p:sp>
         <p:nvSpPr>
-          <p:cNvPr id="92" name="Rounded Rectangle 91"/>
+          <p:cNvPr id="83" name="Oval 82"/>
           <p:cNvSpPr/>
           <p:nvPr/>
         </p:nvSpPr>
         <p:spPr>
           <a:xfrm>
-            <a:off x="4140569" y="5148072"/>
-            <a:ext cx="495596" cy="91440"/>
-          </a:xfrm>
-          <a:prstGeom prst="roundRect">
-            <a:avLst>
-              <a:gd name="adj" fmla="val 50000"/>
-            </a:avLst>
+            <a:off x="4465181" y="5052060"/>
+            <a:ext cx="356616" cy="356616"/>
+          </a:xfrm>
+          <a:prstGeom prst="ellipse">
+            <a:avLst/>
           </a:prstGeom>
           <a:solidFill>
             <a:srgbClr val="0E7490"/>
@@ -6931,14 +6662,49 @@
       </p:sp>
       <p:sp>
         <p:nvSpPr>
-          <p:cNvPr id="93" name="TextBox 92"/>
+          <p:cNvPr id="84" name="TextBox 83"/>
           <p:cNvSpPr txBox="1"/>
           <p:nvPr/>
         </p:nvSpPr>
         <p:spPr>
           <a:xfrm>
-            <a:off x="4140569" y="5175504"/>
-            <a:ext cx="2275193" cy="164592"/>
+            <a:off x="4277729" y="5120640"/>
+            <a:ext cx="731520" cy="219456"/>
+          </a:xfrm>
+          <a:prstGeom prst="rect">
+            <a:avLst/>
+          </a:prstGeom>
+          <a:noFill/>
+        </p:spPr>
+        <p:txBody>
+          <a:bodyPr wrap="square" anchor="ctr" lIns="0" rIns="0" tIns="0" bIns="0">
+            <a:spAutoFit/>
+          </a:bodyPr>
+          <a:lstStyle/>
+          <a:p>
+            <a:pPr algn="ctr"/>
+            <a:r>
+              <a:rPr sz="1200" b="1">
+                <a:solidFill>
+                  <a:srgbClr val="FFFFFF"/>
+                </a:solidFill>
+                <a:latin typeface="Calibri"/>
+              </a:rPr>
+              <a:t>4</a:t>
+            </a:r>
+          </a:p>
+        </p:txBody>
+      </p:sp>
+      <p:sp>
+        <p:nvSpPr>
+          <p:cNvPr id="85" name="TextBox 84"/>
+          <p:cNvSpPr txBox="1"/>
+          <p:nvPr/>
+        </p:nvSpPr>
+        <p:spPr>
+          <a:xfrm>
+            <a:off x="4049129" y="5449824"/>
+            <a:ext cx="1188720" cy="182880"/>
           </a:xfrm>
           <a:prstGeom prst="rect">
             <a:avLst/>
@@ -6951,115 +6717,32 @@
           </a:bodyPr>
           <a:lstStyle/>
           <a:p>
-            <a:pPr algn="l"/>
-            <a:r>
-              <a:rPr sz="1000" b="1">
-                <a:solidFill>
-                  <a:srgbClr val="0F172A"/>
+            <a:pPr algn="ctr"/>
+            <a:r>
+              <a:rPr sz="850" b="1">
+                <a:solidFill>
+                  <a:srgbClr val="64748B"/>
                 </a:solidFill>
                 <a:latin typeface="Calibri"/>
               </a:rPr>
-              <a:t>22–28 Jun</a:t>
-            </a:r>
-          </a:p>
-        </p:txBody>
-      </p:sp>
-      <p:sp>
-        <p:nvSpPr>
-          <p:cNvPr id="94" name="TextBox 93"/>
-          <p:cNvSpPr txBox="1"/>
-          <p:nvPr/>
-        </p:nvSpPr>
-        <p:spPr>
-          <a:xfrm>
-            <a:off x="6415762" y="5175504"/>
-            <a:ext cx="640080" cy="164592"/>
-          </a:xfrm>
-          <a:prstGeom prst="rect">
+              <a:t>18–21 Jun</a:t>
+            </a:r>
+          </a:p>
+        </p:txBody>
+      </p:sp>
+      <p:sp>
+        <p:nvSpPr>
+          <p:cNvPr id="86" name="Oval 85"/>
+          <p:cNvSpPr/>
+          <p:nvPr/>
+        </p:nvSpPr>
+        <p:spPr>
+          <a:xfrm>
+            <a:off x="5305598" y="4937760"/>
+            <a:ext cx="585216" cy="585216"/>
+          </a:xfrm>
+          <a:prstGeom prst="ellipse">
             <a:avLst/>
-          </a:prstGeom>
-          <a:noFill/>
-        </p:spPr>
-        <p:txBody>
-          <a:bodyPr wrap="square" anchor="t" lIns="0" rIns="0" tIns="0" bIns="0">
-            <a:spAutoFit/>
-          </a:bodyPr>
-          <a:lstStyle/>
-          <a:p>
-            <a:pPr algn="r"/>
-            <a:r>
-              <a:rPr sz="1000" b="1">
-                <a:solidFill>
-                  <a:srgbClr val="0F172A"/>
-                </a:solidFill>
-                <a:latin typeface="Calibri"/>
-              </a:rPr>
-              <a:t>24</a:t>
-            </a:r>
-          </a:p>
-        </p:txBody>
-      </p:sp>
-      <p:sp>
-        <p:nvSpPr>
-          <p:cNvPr id="95" name="Rounded Rectangle 94"/>
-          <p:cNvSpPr/>
-          <p:nvPr/>
-        </p:nvSpPr>
-        <p:spPr>
-          <a:xfrm>
-            <a:off x="4140569" y="5349240"/>
-            <a:ext cx="2915273" cy="91440"/>
-          </a:xfrm>
-          <a:prstGeom prst="roundRect">
-            <a:avLst>
-              <a:gd name="adj" fmla="val 50000"/>
-            </a:avLst>
-          </a:prstGeom>
-          <a:solidFill>
-            <a:srgbClr val="ECF1F8"/>
-          </a:solidFill>
-          <a:ln>
-            <a:noFill/>
-          </a:ln>
-          <a:effectLst/>
-        </p:spPr>
-        <p:style>
-          <a:lnRef idx="1">
-            <a:schemeClr val="accent1"/>
-          </a:lnRef>
-          <a:fillRef idx="3">
-            <a:schemeClr val="accent1"/>
-          </a:fillRef>
-          <a:effectRef idx="2">
-            <a:schemeClr val="accent1"/>
-          </a:effectRef>
-          <a:fontRef idx="minor">
-            <a:schemeClr val="lt1"/>
-          </a:fontRef>
-        </p:style>
-        <p:txBody>
-          <a:bodyPr rtlCol="0" anchor="ctr"/>
-          <a:lstStyle/>
-          <a:p>
-            <a:pPr algn="ctr"/>
-          </a:p>
-        </p:txBody>
-      </p:sp>
-      <p:sp>
-        <p:nvSpPr>
-          <p:cNvPr id="96" name="Rounded Rectangle 95"/>
-          <p:cNvSpPr/>
-          <p:nvPr/>
-        </p:nvSpPr>
-        <p:spPr>
-          <a:xfrm>
-            <a:off x="4140569" y="5349240"/>
-            <a:ext cx="2915273" cy="91440"/>
-          </a:xfrm>
-          <a:prstGeom prst="roundRect">
-            <a:avLst>
-              <a:gd name="adj" fmla="val 50000"/>
-            </a:avLst>
           </a:prstGeom>
           <a:solidFill>
             <a:srgbClr val="D97706"/>
@@ -7093,14 +6776,49 @@
       </p:sp>
       <p:sp>
         <p:nvSpPr>
-          <p:cNvPr id="97" name="TextBox 96"/>
+          <p:cNvPr id="87" name="TextBox 86"/>
           <p:cNvSpPr txBox="1"/>
           <p:nvPr/>
         </p:nvSpPr>
         <p:spPr>
           <a:xfrm>
-            <a:off x="4140569" y="5376672"/>
-            <a:ext cx="2275193" cy="164592"/>
+            <a:off x="5232446" y="5120640"/>
+            <a:ext cx="731520" cy="219456"/>
+          </a:xfrm>
+          <a:prstGeom prst="rect">
+            <a:avLst/>
+          </a:prstGeom>
+          <a:noFill/>
+        </p:spPr>
+        <p:txBody>
+          <a:bodyPr wrap="square" anchor="ctr" lIns="0" rIns="0" tIns="0" bIns="0">
+            <a:spAutoFit/>
+          </a:bodyPr>
+          <a:lstStyle/>
+          <a:p>
+            <a:pPr algn="ctr"/>
+            <a:r>
+              <a:rPr sz="1200" b="1">
+                <a:solidFill>
+                  <a:srgbClr val="FFFFFF"/>
+                </a:solidFill>
+                <a:latin typeface="Calibri"/>
+              </a:rPr>
+              <a:t>24</a:t>
+            </a:r>
+          </a:p>
+        </p:txBody>
+      </p:sp>
+      <p:sp>
+        <p:nvSpPr>
+          <p:cNvPr id="88" name="TextBox 87"/>
+          <p:cNvSpPr txBox="1"/>
+          <p:nvPr/>
+        </p:nvSpPr>
+        <p:spPr>
+          <a:xfrm>
+            <a:off x="5003846" y="5449824"/>
+            <a:ext cx="1188720" cy="182880"/>
           </a:xfrm>
           <a:prstGeom prst="rect">
             <a:avLst/>
@@ -7113,115 +6831,32 @@
           </a:bodyPr>
           <a:lstStyle/>
           <a:p>
-            <a:pPr algn="l"/>
-            <a:r>
-              <a:rPr sz="1000" b="1">
-                <a:solidFill>
-                  <a:srgbClr val="0F172A"/>
+            <a:pPr algn="ctr"/>
+            <a:r>
+              <a:rPr sz="850" b="1">
+                <a:solidFill>
+                  <a:srgbClr val="64748B"/>
                 </a:solidFill>
                 <a:latin typeface="Calibri"/>
               </a:rPr>
-              <a:t>29 Jun–1 Jul</a:t>
-            </a:r>
-          </a:p>
-        </p:txBody>
-      </p:sp>
-      <p:sp>
-        <p:nvSpPr>
-          <p:cNvPr id="98" name="TextBox 97"/>
-          <p:cNvSpPr txBox="1"/>
-          <p:nvPr/>
-        </p:nvSpPr>
-        <p:spPr>
-          <a:xfrm>
-            <a:off x="6415762" y="5376672"/>
-            <a:ext cx="640080" cy="164592"/>
-          </a:xfrm>
-          <a:prstGeom prst="rect">
+              <a:t>22–28 Jun</a:t>
+            </a:r>
+          </a:p>
+        </p:txBody>
+      </p:sp>
+      <p:sp>
+        <p:nvSpPr>
+          <p:cNvPr id="89" name="Oval 88"/>
+          <p:cNvSpPr/>
+          <p:nvPr/>
+        </p:nvSpPr>
+        <p:spPr>
+          <a:xfrm>
+            <a:off x="6368899" y="5046345"/>
+            <a:ext cx="368046" cy="368046"/>
+          </a:xfrm>
+          <a:prstGeom prst="ellipse">
             <a:avLst/>
-          </a:prstGeom>
-          <a:noFill/>
-        </p:spPr>
-        <p:txBody>
-          <a:bodyPr wrap="square" anchor="t" lIns="0" rIns="0" tIns="0" bIns="0">
-            <a:spAutoFit/>
-          </a:bodyPr>
-          <a:lstStyle/>
-          <a:p>
-            <a:pPr algn="r"/>
-            <a:r>
-              <a:rPr sz="1000" b="1">
-                <a:solidFill>
-                  <a:srgbClr val="0F172A"/>
-                </a:solidFill>
-                <a:latin typeface="Calibri"/>
-              </a:rPr>
-              <a:t>5</a:t>
-            </a:r>
-          </a:p>
-        </p:txBody>
-      </p:sp>
-      <p:sp>
-        <p:nvSpPr>
-          <p:cNvPr id="99" name="Rounded Rectangle 98"/>
-          <p:cNvSpPr/>
-          <p:nvPr/>
-        </p:nvSpPr>
-        <p:spPr>
-          <a:xfrm>
-            <a:off x="4140569" y="5550408"/>
-            <a:ext cx="2915273" cy="91440"/>
-          </a:xfrm>
-          <a:prstGeom prst="roundRect">
-            <a:avLst>
-              <a:gd name="adj" fmla="val 50000"/>
-            </a:avLst>
-          </a:prstGeom>
-          <a:solidFill>
-            <a:srgbClr val="ECF1F8"/>
-          </a:solidFill>
-          <a:ln>
-            <a:noFill/>
-          </a:ln>
-          <a:effectLst/>
-        </p:spPr>
-        <p:style>
-          <a:lnRef idx="1">
-            <a:schemeClr val="accent1"/>
-          </a:lnRef>
-          <a:fillRef idx="3">
-            <a:schemeClr val="accent1"/>
-          </a:fillRef>
-          <a:effectRef idx="2">
-            <a:schemeClr val="accent1"/>
-          </a:effectRef>
-          <a:fontRef idx="minor">
-            <a:schemeClr val="lt1"/>
-          </a:fontRef>
-        </p:style>
-        <p:txBody>
-          <a:bodyPr rtlCol="0" anchor="ctr"/>
-          <a:lstStyle/>
-          <a:p>
-            <a:pPr algn="ctr"/>
-          </a:p>
-        </p:txBody>
-      </p:sp>
-      <p:sp>
-        <p:nvSpPr>
-          <p:cNvPr id="100" name="Rounded Rectangle 99"/>
-          <p:cNvSpPr/>
-          <p:nvPr/>
-        </p:nvSpPr>
-        <p:spPr>
-          <a:xfrm>
-            <a:off x="4140569" y="5550408"/>
-            <a:ext cx="612207" cy="91440"/>
-          </a:xfrm>
-          <a:prstGeom prst="roundRect">
-            <a:avLst>
-              <a:gd name="adj" fmla="val 50000"/>
-            </a:avLst>
           </a:prstGeom>
           <a:solidFill>
             <a:srgbClr val="0E7490"/>
@@ -7255,7 +6890,77 @@
       </p:sp>
       <p:sp>
         <p:nvSpPr>
-          <p:cNvPr id="101" name="Rounded Rectangle 100"/>
+          <p:cNvPr id="90" name="TextBox 89"/>
+          <p:cNvSpPr txBox="1"/>
+          <p:nvPr/>
+        </p:nvSpPr>
+        <p:spPr>
+          <a:xfrm>
+            <a:off x="6187162" y="5120640"/>
+            <a:ext cx="731520" cy="219456"/>
+          </a:xfrm>
+          <a:prstGeom prst="rect">
+            <a:avLst/>
+          </a:prstGeom>
+          <a:noFill/>
+        </p:spPr>
+        <p:txBody>
+          <a:bodyPr wrap="square" anchor="ctr" lIns="0" rIns="0" tIns="0" bIns="0">
+            <a:spAutoFit/>
+          </a:bodyPr>
+          <a:lstStyle/>
+          <a:p>
+            <a:pPr algn="ctr"/>
+            <a:r>
+              <a:rPr sz="1200" b="1">
+                <a:solidFill>
+                  <a:srgbClr val="FFFFFF"/>
+                </a:solidFill>
+                <a:latin typeface="Calibri"/>
+              </a:rPr>
+              <a:t>5</a:t>
+            </a:r>
+          </a:p>
+        </p:txBody>
+      </p:sp>
+      <p:sp>
+        <p:nvSpPr>
+          <p:cNvPr id="91" name="TextBox 90"/>
+          <p:cNvSpPr txBox="1"/>
+          <p:nvPr/>
+        </p:nvSpPr>
+        <p:spPr>
+          <a:xfrm>
+            <a:off x="5958562" y="5449824"/>
+            <a:ext cx="1188720" cy="182880"/>
+          </a:xfrm>
+          <a:prstGeom prst="rect">
+            <a:avLst/>
+          </a:prstGeom>
+          <a:noFill/>
+        </p:spPr>
+        <p:txBody>
+          <a:bodyPr wrap="square" anchor="t" lIns="0" rIns="0" tIns="0" bIns="0">
+            <a:spAutoFit/>
+          </a:bodyPr>
+          <a:lstStyle/>
+          <a:p>
+            <a:pPr algn="ctr"/>
+            <a:r>
+              <a:rPr sz="850" b="1">
+                <a:solidFill>
+                  <a:srgbClr val="64748B"/>
+                </a:solidFill>
+                <a:latin typeface="Calibri"/>
+              </a:rPr>
+              <a:t>29 Jun–1 Jul</a:t>
+            </a:r>
+          </a:p>
+        </p:txBody>
+      </p:sp>
+      <p:sp>
+        <p:nvSpPr>
+          <p:cNvPr id="92" name="Rounded Rectangle 91"/>
           <p:cNvSpPr/>
           <p:nvPr/>
         </p:nvSpPr>
@@ -7303,7 +7008,7 @@
       </p:sp>
       <p:sp>
         <p:nvSpPr>
-          <p:cNvPr id="102" name="Rounded Rectangle 101"/>
+          <p:cNvPr id="93" name="Rounded Rectangle 92"/>
           <p:cNvSpPr/>
           <p:nvPr/>
         </p:nvSpPr>
@@ -7349,7 +7054,7 @@
       </p:sp>
       <p:sp>
         <p:nvSpPr>
-          <p:cNvPr id="103" name="TextBox 102"/>
+          <p:cNvPr id="94" name="TextBox 93"/>
           <p:cNvSpPr txBox="1"/>
           <p:nvPr/>
         </p:nvSpPr>
@@ -7384,7 +7089,7 @@
       </p:sp>
       <p:sp>
         <p:nvSpPr>
-          <p:cNvPr id="104" name="Rounded Rectangle 103"/>
+          <p:cNvPr id="95" name="Rounded Rectangle 94"/>
           <p:cNvSpPr/>
           <p:nvPr/>
         </p:nvSpPr>
@@ -7432,7 +7137,7 @@
       </p:sp>
       <p:sp>
         <p:nvSpPr>
-          <p:cNvPr id="105" name="Rounded Rectangle 104"/>
+          <p:cNvPr id="96" name="Rounded Rectangle 95"/>
           <p:cNvSpPr/>
           <p:nvPr/>
         </p:nvSpPr>
@@ -7478,7 +7183,7 @@
       </p:sp>
       <p:sp>
         <p:nvSpPr>
-          <p:cNvPr id="106" name="TextBox 105"/>
+          <p:cNvPr id="97" name="TextBox 96"/>
           <p:cNvSpPr txBox="1"/>
           <p:nvPr/>
         </p:nvSpPr>
@@ -7513,7 +7218,7 @@
       </p:sp>
       <p:sp>
         <p:nvSpPr>
-          <p:cNvPr id="107" name="TextBox 106"/>
+          <p:cNvPr id="98" name="TextBox 97"/>
           <p:cNvSpPr txBox="1"/>
           <p:nvPr/>
         </p:nvSpPr>
@@ -7548,7 +7253,7 @@
       </p:sp>
       <p:sp>
         <p:nvSpPr>
-          <p:cNvPr id="108" name="TextBox 107"/>
+          <p:cNvPr id="99" name="TextBox 98"/>
           <p:cNvSpPr txBox="1"/>
           <p:nvPr/>
         </p:nvSpPr>
@@ -7587,7 +7292,7 @@
       </p:sp>
       <p:sp>
         <p:nvSpPr>
-          <p:cNvPr id="109" name="TextBox 108"/>
+          <p:cNvPr id="100" name="TextBox 99"/>
           <p:cNvSpPr txBox="1"/>
           <p:nvPr/>
         </p:nvSpPr>
@@ -7622,7 +7327,7 @@
       </p:sp>
       <p:sp>
         <p:nvSpPr>
-          <p:cNvPr id="110" name="TextBox 109"/>
+          <p:cNvPr id="101" name="TextBox 100"/>
           <p:cNvSpPr txBox="1"/>
           <p:nvPr/>
         </p:nvSpPr>
@@ -7657,7 +7362,7 @@
       </p:sp>
       <p:sp>
         <p:nvSpPr>
-          <p:cNvPr id="111" name="Rounded Rectangle 110"/>
+          <p:cNvPr id="102" name="Rounded Rectangle 101"/>
           <p:cNvSpPr/>
           <p:nvPr/>
         </p:nvSpPr>
@@ -7705,7 +7410,7 @@
       </p:sp>
       <p:sp>
         <p:nvSpPr>
-          <p:cNvPr id="112" name="Rounded Rectangle 111"/>
+          <p:cNvPr id="103" name="Rounded Rectangle 102"/>
           <p:cNvSpPr/>
           <p:nvPr/>
         </p:nvSpPr>
@@ -7751,7 +7456,7 @@
       </p:sp>
       <p:sp>
         <p:nvSpPr>
-          <p:cNvPr id="113" name="TextBox 112"/>
+          <p:cNvPr id="104" name="TextBox 103"/>
           <p:cNvSpPr txBox="1"/>
           <p:nvPr/>
         </p:nvSpPr>
@@ -7786,7 +7491,7 @@
       </p:sp>
       <p:sp>
         <p:nvSpPr>
-          <p:cNvPr id="114" name="TextBox 113"/>
+          <p:cNvPr id="105" name="TextBox 104"/>
           <p:cNvSpPr txBox="1"/>
           <p:nvPr/>
         </p:nvSpPr>
@@ -7821,7 +7526,7 @@
       </p:sp>
       <p:sp>
         <p:nvSpPr>
-          <p:cNvPr id="115" name="TextBox 114"/>
+          <p:cNvPr id="106" name="TextBox 105"/>
           <p:cNvSpPr txBox="1"/>
           <p:nvPr/>
         </p:nvSpPr>
@@ -7860,7 +7565,7 @@
       </p:sp>
       <p:sp>
         <p:nvSpPr>
-          <p:cNvPr id="116" name="TextBox 115"/>
+          <p:cNvPr id="107" name="TextBox 106"/>
           <p:cNvSpPr txBox="1"/>
           <p:nvPr/>
         </p:nvSpPr>
@@ -7895,7 +7600,7 @@
       </p:sp>
       <p:sp>
         <p:nvSpPr>
-          <p:cNvPr id="117" name="TextBox 116"/>
+          <p:cNvPr id="108" name="TextBox 107"/>
           <p:cNvSpPr txBox="1"/>
           <p:nvPr/>
         </p:nvSpPr>
@@ -7930,7 +7635,7 @@
       </p:sp>
       <p:sp>
         <p:nvSpPr>
-          <p:cNvPr id="118" name="Rounded Rectangle 117"/>
+          <p:cNvPr id="109" name="Rounded Rectangle 108"/>
           <p:cNvSpPr/>
           <p:nvPr/>
         </p:nvSpPr>
@@ -7978,7 +7683,7 @@
       </p:sp>
       <p:sp>
         <p:nvSpPr>
-          <p:cNvPr id="119" name="Rounded Rectangle 118"/>
+          <p:cNvPr id="110" name="Rounded Rectangle 109"/>
           <p:cNvSpPr/>
           <p:nvPr/>
         </p:nvSpPr>
@@ -8024,7 +7729,7 @@
       </p:sp>
       <p:sp>
         <p:nvSpPr>
-          <p:cNvPr id="120" name="TextBox 119"/>
+          <p:cNvPr id="111" name="TextBox 110"/>
           <p:cNvSpPr txBox="1"/>
           <p:nvPr/>
         </p:nvSpPr>
@@ -8059,7 +7764,7 @@
       </p:sp>
       <p:sp>
         <p:nvSpPr>
-          <p:cNvPr id="121" name="TextBox 120"/>
+          <p:cNvPr id="112" name="TextBox 111"/>
           <p:cNvSpPr txBox="1"/>
           <p:nvPr/>
         </p:nvSpPr>
@@ -8094,7 +7799,7 @@
       </p:sp>
       <p:sp>
         <p:nvSpPr>
-          <p:cNvPr id="122" name="TextBox 121"/>
+          <p:cNvPr id="113" name="TextBox 112"/>
           <p:cNvSpPr txBox="1"/>
           <p:nvPr/>
         </p:nvSpPr>
@@ -8133,7 +7838,7 @@
       </p:sp>
       <p:sp>
         <p:nvSpPr>
-          <p:cNvPr id="123" name="TextBox 122"/>
+          <p:cNvPr id="114" name="TextBox 113"/>
           <p:cNvSpPr txBox="1"/>
           <p:nvPr/>
         </p:nvSpPr>
@@ -8168,7 +7873,7 @@
       </p:sp>
       <p:sp>
         <p:nvSpPr>
-          <p:cNvPr id="124" name="TextBox 123"/>
+          <p:cNvPr id="115" name="TextBox 114"/>
           <p:cNvSpPr txBox="1"/>
           <p:nvPr/>
         </p:nvSpPr>
@@ -8203,7 +7908,7 @@
       </p:sp>
       <p:sp>
         <p:nvSpPr>
-          <p:cNvPr id="125" name="Rounded Rectangle 124"/>
+          <p:cNvPr id="116" name="Rounded Rectangle 115"/>
           <p:cNvSpPr/>
           <p:nvPr/>
         </p:nvSpPr>
@@ -8251,7 +7956,7 @@
       </p:sp>
       <p:sp>
         <p:nvSpPr>
-          <p:cNvPr id="126" name="Rounded Rectangle 125"/>
+          <p:cNvPr id="117" name="Rounded Rectangle 116"/>
           <p:cNvSpPr/>
           <p:nvPr/>
         </p:nvSpPr>
@@ -8297,7 +8002,7 @@
       </p:sp>
       <p:sp>
         <p:nvSpPr>
-          <p:cNvPr id="127" name="TextBox 126"/>
+          <p:cNvPr id="118" name="TextBox 117"/>
           <p:cNvSpPr txBox="1"/>
           <p:nvPr/>
         </p:nvSpPr>
@@ -8332,7 +8037,7 @@
       </p:sp>
       <p:sp>
         <p:nvSpPr>
-          <p:cNvPr id="128" name="TextBox 127"/>
+          <p:cNvPr id="119" name="TextBox 118"/>
           <p:cNvSpPr txBox="1"/>
           <p:nvPr/>
         </p:nvSpPr>
@@ -8367,7 +8072,7 @@
       </p:sp>
       <p:sp>
         <p:nvSpPr>
-          <p:cNvPr id="129" name="TextBox 128"/>
+          <p:cNvPr id="120" name="TextBox 119"/>
           <p:cNvSpPr txBox="1"/>
           <p:nvPr/>
         </p:nvSpPr>
@@ -8406,7 +8111,7 @@
       </p:sp>
       <p:sp>
         <p:nvSpPr>
-          <p:cNvPr id="130" name="TextBox 129"/>
+          <p:cNvPr id="121" name="TextBox 120"/>
           <p:cNvSpPr txBox="1"/>
           <p:nvPr/>
         </p:nvSpPr>
@@ -8441,7 +8146,7 @@
       </p:sp>
       <p:sp>
         <p:nvSpPr>
-          <p:cNvPr id="131" name="TextBox 130"/>
+          <p:cNvPr id="122" name="TextBox 121"/>
           <p:cNvSpPr txBox="1"/>
           <p:nvPr/>
         </p:nvSpPr>
@@ -8476,7 +8181,7 @@
       </p:sp>
       <p:sp>
         <p:nvSpPr>
-          <p:cNvPr id="132" name="Rounded Rectangle 131"/>
+          <p:cNvPr id="123" name="Rounded Rectangle 122"/>
           <p:cNvSpPr/>
           <p:nvPr/>
         </p:nvSpPr>
@@ -8524,7 +8229,7 @@
       </p:sp>
       <p:sp>
         <p:nvSpPr>
-          <p:cNvPr id="133" name="TextBox 132"/>
+          <p:cNvPr id="124" name="TextBox 123"/>
           <p:cNvSpPr txBox="1"/>
           <p:nvPr/>
         </p:nvSpPr>
@@ -8559,7 +8264,7 @@
       </p:sp>
       <p:sp>
         <p:nvSpPr>
-          <p:cNvPr id="134" name="TextBox 133"/>
+          <p:cNvPr id="125" name="TextBox 124"/>
           <p:cNvSpPr txBox="1"/>
           <p:nvPr/>
         </p:nvSpPr>
@@ -8625,7 +8330,7 @@
       </p:sp>
       <p:sp>
         <p:nvSpPr>
-          <p:cNvPr id="135" name="Rounded Rectangle 134"/>
+          <p:cNvPr id="126" name="Rounded Rectangle 125"/>
           <p:cNvSpPr/>
           <p:nvPr/>
         </p:nvSpPr>
@@ -8673,7 +8378,7 @@
       </p:sp>
       <p:sp>
         <p:nvSpPr>
-          <p:cNvPr id="136" name="TextBox 135"/>
+          <p:cNvPr id="127" name="TextBox 126"/>
           <p:cNvSpPr txBox="1"/>
           <p:nvPr/>
         </p:nvSpPr>
@@ -8728,7 +8433,7 @@
       </p:sp>
       <p:sp>
         <p:nvSpPr>
-          <p:cNvPr id="137" name="TextBox 136"/>
+          <p:cNvPr id="128" name="TextBox 127"/>
           <p:cNvSpPr txBox="1"/>
           <p:nvPr/>
         </p:nvSpPr>

</xml_diff>